<commit_message>
Fix PPTX compatibility — replace connector shapes with text arrows
Connector shapes from python-pptx caused some PowerPoint versions to fail opening
the files. Replaced all add_connector() calls with simple text arrow (→) shapes
which are universally compatible.

Co-Authored-By: Claude Sonnet 4.6 <noreply@anthropic.com>
</commit_message>
<xml_diff>
--- a/test/NHS_Project_Presentation.pptx
+++ b/test/NHS_Project_Presentation.pptx
@@ -14766,181 +14766,181 @@
           </a:p>
         </p:txBody>
       </p:sp>
-      <p:cxnSp>
-        <p:nvCxnSpPr>
-          <p:cNvPr id="20" name="Connector 19"/>
-          <p:cNvCxnSpPr/>
-          <p:nvPr/>
-        </p:nvCxnSpPr>
-        <p:spPr>
-          <a:xfrm>
-            <a:off x="2049780" y="1746504"/>
-            <a:ext cx="219456" cy="0"/>
-          </a:xfrm>
-          <a:prstGeom prst="line">
-            <a:avLst/>
-          </a:prstGeom>
-          <a:ln w="19050">
-            <a:solidFill>
-              <a:srgbClr val="005EB8"/>
-            </a:solidFill>
-          </a:ln>
-        </p:spPr>
-        <p:style>
-          <a:lnRef idx="2">
-            <a:schemeClr val="accent1"/>
-          </a:lnRef>
-          <a:fillRef idx="0">
-            <a:schemeClr val="accent1"/>
-          </a:fillRef>
-          <a:effectRef idx="1">
-            <a:schemeClr val="accent1"/>
-          </a:effectRef>
-          <a:fontRef idx="minor">
-            <a:schemeClr val="tx1"/>
-          </a:fontRef>
-        </p:style>
-      </p:cxnSp>
-      <p:cxnSp>
-        <p:nvCxnSpPr>
-          <p:cNvPr id="21" name="Connector 20"/>
-          <p:cNvCxnSpPr/>
-          <p:nvPr/>
-        </p:nvCxnSpPr>
-        <p:spPr>
-          <a:xfrm>
-            <a:off x="4017264" y="1746504"/>
-            <a:ext cx="219456" cy="0"/>
-          </a:xfrm>
-          <a:prstGeom prst="line">
-            <a:avLst/>
-          </a:prstGeom>
-          <a:ln w="19050">
-            <a:solidFill>
-              <a:srgbClr val="005EB8"/>
-            </a:solidFill>
-          </a:ln>
-        </p:spPr>
-        <p:style>
-          <a:lnRef idx="2">
-            <a:schemeClr val="accent1"/>
-          </a:lnRef>
-          <a:fillRef idx="0">
-            <a:schemeClr val="accent1"/>
-          </a:fillRef>
-          <a:effectRef idx="1">
-            <a:schemeClr val="accent1"/>
-          </a:effectRef>
-          <a:fontRef idx="minor">
-            <a:schemeClr val="tx1"/>
-          </a:fontRef>
-        </p:style>
-      </p:cxnSp>
-      <p:cxnSp>
-        <p:nvCxnSpPr>
-          <p:cNvPr id="22" name="Connector 21"/>
-          <p:cNvCxnSpPr/>
-          <p:nvPr/>
-        </p:nvCxnSpPr>
-        <p:spPr>
-          <a:xfrm>
-            <a:off x="5984748" y="1746504"/>
-            <a:ext cx="219456" cy="0"/>
-          </a:xfrm>
-          <a:prstGeom prst="line">
-            <a:avLst/>
-          </a:prstGeom>
-          <a:ln w="19050">
-            <a:solidFill>
-              <a:srgbClr val="005EB8"/>
-            </a:solidFill>
-          </a:ln>
-        </p:spPr>
-        <p:style>
-          <a:lnRef idx="2">
-            <a:schemeClr val="accent1"/>
-          </a:lnRef>
-          <a:fillRef idx="0">
-            <a:schemeClr val="accent1"/>
-          </a:fillRef>
-          <a:effectRef idx="1">
-            <a:schemeClr val="accent1"/>
-          </a:effectRef>
-          <a:fontRef idx="minor">
-            <a:schemeClr val="tx1"/>
-          </a:fontRef>
-        </p:style>
-      </p:cxnSp>
-      <p:cxnSp>
-        <p:nvCxnSpPr>
-          <p:cNvPr id="23" name="Connector 22"/>
-          <p:cNvCxnSpPr/>
-          <p:nvPr/>
-        </p:nvCxnSpPr>
-        <p:spPr>
-          <a:xfrm>
-            <a:off x="7952232" y="1746504"/>
-            <a:ext cx="219456" cy="0"/>
-          </a:xfrm>
-          <a:prstGeom prst="line">
-            <a:avLst/>
-          </a:prstGeom>
-          <a:ln w="19050">
-            <a:solidFill>
-              <a:srgbClr val="005EB8"/>
-            </a:solidFill>
-          </a:ln>
-        </p:spPr>
-        <p:style>
-          <a:lnRef idx="2">
-            <a:schemeClr val="accent1"/>
-          </a:lnRef>
-          <a:fillRef idx="0">
-            <a:schemeClr val="accent1"/>
-          </a:fillRef>
-          <a:effectRef idx="1">
-            <a:schemeClr val="accent1"/>
-          </a:effectRef>
-          <a:fontRef idx="minor">
-            <a:schemeClr val="tx1"/>
-          </a:fontRef>
-        </p:style>
-      </p:cxnSp>
-      <p:cxnSp>
-        <p:nvCxnSpPr>
-          <p:cNvPr id="24" name="Connector 23"/>
-          <p:cNvCxnSpPr/>
-          <p:nvPr/>
-        </p:nvCxnSpPr>
-        <p:spPr>
-          <a:xfrm>
-            <a:off x="9919716" y="1746504"/>
-            <a:ext cx="219456" cy="0"/>
-          </a:xfrm>
-          <a:prstGeom prst="line">
-            <a:avLst/>
-          </a:prstGeom>
-          <a:ln w="19050">
-            <a:solidFill>
-              <a:srgbClr val="005EB8"/>
-            </a:solidFill>
-          </a:ln>
-        </p:spPr>
-        <p:style>
-          <a:lnRef idx="2">
-            <a:schemeClr val="accent1"/>
-          </a:lnRef>
-          <a:fillRef idx="0">
-            <a:schemeClr val="accent1"/>
-          </a:fillRef>
-          <a:effectRef idx="1">
-            <a:schemeClr val="accent1"/>
-          </a:effectRef>
-          <a:fontRef idx="minor">
-            <a:schemeClr val="tx1"/>
-          </a:fontRef>
-        </p:style>
-      </p:cxnSp>
+      <p:sp>
+        <p:nvSpPr>
+          <p:cNvPr id="20" name="TextBox 19"/>
+          <p:cNvSpPr txBox="1"/>
+          <p:nvPr/>
+        </p:nvSpPr>
+        <p:spPr>
+          <a:xfrm>
+            <a:off x="2031492" y="1609344"/>
+            <a:ext cx="256032" cy="274320"/>
+          </a:xfrm>
+          <a:prstGeom prst="rect">
+            <a:avLst/>
+          </a:prstGeom>
+          <a:noFill/>
+        </p:spPr>
+        <p:txBody>
+          <a:bodyPr wrap="square">
+            <a:spAutoFit/>
+          </a:bodyPr>
+          <a:lstStyle/>
+          <a:p>
+            <a:pPr algn="ctr"/>
+            <a:r>
+              <a:rPr sz="1400" b="1" i="0">
+                <a:solidFill>
+                  <a:srgbClr val="005EB8"/>
+                </a:solidFill>
+                <a:latin typeface="Arial"/>
+              </a:rPr>
+              <a:t>→</a:t>
+            </a:r>
+          </a:p>
+        </p:txBody>
+      </p:sp>
+      <p:sp>
+        <p:nvSpPr>
+          <p:cNvPr id="21" name="TextBox 20"/>
+          <p:cNvSpPr txBox="1"/>
+          <p:nvPr/>
+        </p:nvSpPr>
+        <p:spPr>
+          <a:xfrm>
+            <a:off x="3998976" y="1609344"/>
+            <a:ext cx="256032" cy="274320"/>
+          </a:xfrm>
+          <a:prstGeom prst="rect">
+            <a:avLst/>
+          </a:prstGeom>
+          <a:noFill/>
+        </p:spPr>
+        <p:txBody>
+          <a:bodyPr wrap="square">
+            <a:spAutoFit/>
+          </a:bodyPr>
+          <a:lstStyle/>
+          <a:p>
+            <a:pPr algn="ctr"/>
+            <a:r>
+              <a:rPr sz="1400" b="1" i="0">
+                <a:solidFill>
+                  <a:srgbClr val="005EB8"/>
+                </a:solidFill>
+                <a:latin typeface="Arial"/>
+              </a:rPr>
+              <a:t>→</a:t>
+            </a:r>
+          </a:p>
+        </p:txBody>
+      </p:sp>
+      <p:sp>
+        <p:nvSpPr>
+          <p:cNvPr id="22" name="TextBox 21"/>
+          <p:cNvSpPr txBox="1"/>
+          <p:nvPr/>
+        </p:nvSpPr>
+        <p:spPr>
+          <a:xfrm>
+            <a:off x="5966460" y="1609344"/>
+            <a:ext cx="256032" cy="274320"/>
+          </a:xfrm>
+          <a:prstGeom prst="rect">
+            <a:avLst/>
+          </a:prstGeom>
+          <a:noFill/>
+        </p:spPr>
+        <p:txBody>
+          <a:bodyPr wrap="square">
+            <a:spAutoFit/>
+          </a:bodyPr>
+          <a:lstStyle/>
+          <a:p>
+            <a:pPr algn="ctr"/>
+            <a:r>
+              <a:rPr sz="1400" b="1" i="0">
+                <a:solidFill>
+                  <a:srgbClr val="005EB8"/>
+                </a:solidFill>
+                <a:latin typeface="Arial"/>
+              </a:rPr>
+              <a:t>→</a:t>
+            </a:r>
+          </a:p>
+        </p:txBody>
+      </p:sp>
+      <p:sp>
+        <p:nvSpPr>
+          <p:cNvPr id="23" name="TextBox 22"/>
+          <p:cNvSpPr txBox="1"/>
+          <p:nvPr/>
+        </p:nvSpPr>
+        <p:spPr>
+          <a:xfrm>
+            <a:off x="7933944" y="1609344"/>
+            <a:ext cx="256032" cy="274320"/>
+          </a:xfrm>
+          <a:prstGeom prst="rect">
+            <a:avLst/>
+          </a:prstGeom>
+          <a:noFill/>
+        </p:spPr>
+        <p:txBody>
+          <a:bodyPr wrap="square">
+            <a:spAutoFit/>
+          </a:bodyPr>
+          <a:lstStyle/>
+          <a:p>
+            <a:pPr algn="ctr"/>
+            <a:r>
+              <a:rPr sz="1400" b="1" i="0">
+                <a:solidFill>
+                  <a:srgbClr val="005EB8"/>
+                </a:solidFill>
+                <a:latin typeface="Arial"/>
+              </a:rPr>
+              <a:t>→</a:t>
+            </a:r>
+          </a:p>
+        </p:txBody>
+      </p:sp>
+      <p:sp>
+        <p:nvSpPr>
+          <p:cNvPr id="24" name="TextBox 23"/>
+          <p:cNvSpPr txBox="1"/>
+          <p:nvPr/>
+        </p:nvSpPr>
+        <p:spPr>
+          <a:xfrm>
+            <a:off x="9901428" y="1609344"/>
+            <a:ext cx="256032" cy="274320"/>
+          </a:xfrm>
+          <a:prstGeom prst="rect">
+            <a:avLst/>
+          </a:prstGeom>
+          <a:noFill/>
+        </p:spPr>
+        <p:txBody>
+          <a:bodyPr wrap="square">
+            <a:spAutoFit/>
+          </a:bodyPr>
+          <a:lstStyle/>
+          <a:p>
+            <a:pPr algn="ctr"/>
+            <a:r>
+              <a:rPr sz="1400" b="1" i="0">
+                <a:solidFill>
+                  <a:srgbClr val="005EB8"/>
+                </a:solidFill>
+                <a:latin typeface="Arial"/>
+              </a:rPr>
+              <a:t>→</a:t>
+            </a:r>
+          </a:p>
+        </p:txBody>
+      </p:sp>
       <p:sp>
         <p:nvSpPr>
           <p:cNvPr id="25" name="TextBox 24"/>
@@ -15450,181 +15450,181 @@
           </a:p>
         </p:txBody>
       </p:sp>
-      <p:cxnSp>
-        <p:nvCxnSpPr>
-          <p:cNvPr id="38" name="Connector 37"/>
-          <p:cNvCxnSpPr/>
-          <p:nvPr/>
-        </p:nvCxnSpPr>
-        <p:spPr>
-          <a:xfrm>
-            <a:off x="2049780" y="3163824"/>
-            <a:ext cx="219456" cy="0"/>
-          </a:xfrm>
-          <a:prstGeom prst="line">
-            <a:avLst/>
-          </a:prstGeom>
-          <a:ln w="19050">
-            <a:solidFill>
-              <a:srgbClr val="005EB8"/>
-            </a:solidFill>
-          </a:ln>
-        </p:spPr>
-        <p:style>
-          <a:lnRef idx="2">
-            <a:schemeClr val="accent1"/>
-          </a:lnRef>
-          <a:fillRef idx="0">
-            <a:schemeClr val="accent1"/>
-          </a:fillRef>
-          <a:effectRef idx="1">
-            <a:schemeClr val="accent1"/>
-          </a:effectRef>
-          <a:fontRef idx="minor">
-            <a:schemeClr val="tx1"/>
-          </a:fontRef>
-        </p:style>
-      </p:cxnSp>
-      <p:cxnSp>
-        <p:nvCxnSpPr>
-          <p:cNvPr id="39" name="Connector 38"/>
-          <p:cNvCxnSpPr/>
-          <p:nvPr/>
-        </p:nvCxnSpPr>
-        <p:spPr>
-          <a:xfrm>
-            <a:off x="4017264" y="3163824"/>
-            <a:ext cx="219456" cy="0"/>
-          </a:xfrm>
-          <a:prstGeom prst="line">
-            <a:avLst/>
-          </a:prstGeom>
-          <a:ln w="19050">
-            <a:solidFill>
-              <a:srgbClr val="005EB8"/>
-            </a:solidFill>
-          </a:ln>
-        </p:spPr>
-        <p:style>
-          <a:lnRef idx="2">
-            <a:schemeClr val="accent1"/>
-          </a:lnRef>
-          <a:fillRef idx="0">
-            <a:schemeClr val="accent1"/>
-          </a:fillRef>
-          <a:effectRef idx="1">
-            <a:schemeClr val="accent1"/>
-          </a:effectRef>
-          <a:fontRef idx="minor">
-            <a:schemeClr val="tx1"/>
-          </a:fontRef>
-        </p:style>
-      </p:cxnSp>
-      <p:cxnSp>
-        <p:nvCxnSpPr>
-          <p:cNvPr id="40" name="Connector 39"/>
-          <p:cNvCxnSpPr/>
-          <p:nvPr/>
-        </p:nvCxnSpPr>
-        <p:spPr>
-          <a:xfrm>
-            <a:off x="5984748" y="3163824"/>
-            <a:ext cx="219456" cy="0"/>
-          </a:xfrm>
-          <a:prstGeom prst="line">
-            <a:avLst/>
-          </a:prstGeom>
-          <a:ln w="19050">
-            <a:solidFill>
-              <a:srgbClr val="005EB8"/>
-            </a:solidFill>
-          </a:ln>
-        </p:spPr>
-        <p:style>
-          <a:lnRef idx="2">
-            <a:schemeClr val="accent1"/>
-          </a:lnRef>
-          <a:fillRef idx="0">
-            <a:schemeClr val="accent1"/>
-          </a:fillRef>
-          <a:effectRef idx="1">
-            <a:schemeClr val="accent1"/>
-          </a:effectRef>
-          <a:fontRef idx="minor">
-            <a:schemeClr val="tx1"/>
-          </a:fontRef>
-        </p:style>
-      </p:cxnSp>
-      <p:cxnSp>
-        <p:nvCxnSpPr>
-          <p:cNvPr id="41" name="Connector 40"/>
-          <p:cNvCxnSpPr/>
-          <p:nvPr/>
-        </p:nvCxnSpPr>
-        <p:spPr>
-          <a:xfrm>
-            <a:off x="7952232" y="3163824"/>
-            <a:ext cx="219456" cy="0"/>
-          </a:xfrm>
-          <a:prstGeom prst="line">
-            <a:avLst/>
-          </a:prstGeom>
-          <a:ln w="19050">
-            <a:solidFill>
-              <a:srgbClr val="005EB8"/>
-            </a:solidFill>
-          </a:ln>
-        </p:spPr>
-        <p:style>
-          <a:lnRef idx="2">
-            <a:schemeClr val="accent1"/>
-          </a:lnRef>
-          <a:fillRef idx="0">
-            <a:schemeClr val="accent1"/>
-          </a:fillRef>
-          <a:effectRef idx="1">
-            <a:schemeClr val="accent1"/>
-          </a:effectRef>
-          <a:fontRef idx="minor">
-            <a:schemeClr val="tx1"/>
-          </a:fontRef>
-        </p:style>
-      </p:cxnSp>
-      <p:cxnSp>
-        <p:nvCxnSpPr>
-          <p:cNvPr id="42" name="Connector 41"/>
-          <p:cNvCxnSpPr/>
-          <p:nvPr/>
-        </p:nvCxnSpPr>
-        <p:spPr>
-          <a:xfrm>
-            <a:off x="9919716" y="3163824"/>
-            <a:ext cx="219456" cy="0"/>
-          </a:xfrm>
-          <a:prstGeom prst="line">
-            <a:avLst/>
-          </a:prstGeom>
-          <a:ln w="19050">
-            <a:solidFill>
-              <a:srgbClr val="005EB8"/>
-            </a:solidFill>
-          </a:ln>
-        </p:spPr>
-        <p:style>
-          <a:lnRef idx="2">
-            <a:schemeClr val="accent1"/>
-          </a:lnRef>
-          <a:fillRef idx="0">
-            <a:schemeClr val="accent1"/>
-          </a:fillRef>
-          <a:effectRef idx="1">
-            <a:schemeClr val="accent1"/>
-          </a:effectRef>
-          <a:fontRef idx="minor">
-            <a:schemeClr val="tx1"/>
-          </a:fontRef>
-        </p:style>
-      </p:cxnSp>
+      <p:sp>
+        <p:nvSpPr>
+          <p:cNvPr id="38" name="TextBox 37"/>
+          <p:cNvSpPr txBox="1"/>
+          <p:nvPr/>
+        </p:nvSpPr>
+        <p:spPr>
+          <a:xfrm>
+            <a:off x="2031492" y="3026664"/>
+            <a:ext cx="256032" cy="274320"/>
+          </a:xfrm>
+          <a:prstGeom prst="rect">
+            <a:avLst/>
+          </a:prstGeom>
+          <a:noFill/>
+        </p:spPr>
+        <p:txBody>
+          <a:bodyPr wrap="square">
+            <a:spAutoFit/>
+          </a:bodyPr>
+          <a:lstStyle/>
+          <a:p>
+            <a:pPr algn="ctr"/>
+            <a:r>
+              <a:rPr sz="1400" b="1" i="0">
+                <a:solidFill>
+                  <a:srgbClr val="005EB8"/>
+                </a:solidFill>
+                <a:latin typeface="Arial"/>
+              </a:rPr>
+              <a:t>→</a:t>
+            </a:r>
+          </a:p>
+        </p:txBody>
+      </p:sp>
+      <p:sp>
+        <p:nvSpPr>
+          <p:cNvPr id="39" name="TextBox 38"/>
+          <p:cNvSpPr txBox="1"/>
+          <p:nvPr/>
+        </p:nvSpPr>
+        <p:spPr>
+          <a:xfrm>
+            <a:off x="3998976" y="3026664"/>
+            <a:ext cx="256032" cy="274320"/>
+          </a:xfrm>
+          <a:prstGeom prst="rect">
+            <a:avLst/>
+          </a:prstGeom>
+          <a:noFill/>
+        </p:spPr>
+        <p:txBody>
+          <a:bodyPr wrap="square">
+            <a:spAutoFit/>
+          </a:bodyPr>
+          <a:lstStyle/>
+          <a:p>
+            <a:pPr algn="ctr"/>
+            <a:r>
+              <a:rPr sz="1400" b="1" i="0">
+                <a:solidFill>
+                  <a:srgbClr val="005EB8"/>
+                </a:solidFill>
+                <a:latin typeface="Arial"/>
+              </a:rPr>
+              <a:t>→</a:t>
+            </a:r>
+          </a:p>
+        </p:txBody>
+      </p:sp>
+      <p:sp>
+        <p:nvSpPr>
+          <p:cNvPr id="40" name="TextBox 39"/>
+          <p:cNvSpPr txBox="1"/>
+          <p:nvPr/>
+        </p:nvSpPr>
+        <p:spPr>
+          <a:xfrm>
+            <a:off x="5966460" y="3026664"/>
+            <a:ext cx="256032" cy="274320"/>
+          </a:xfrm>
+          <a:prstGeom prst="rect">
+            <a:avLst/>
+          </a:prstGeom>
+          <a:noFill/>
+        </p:spPr>
+        <p:txBody>
+          <a:bodyPr wrap="square">
+            <a:spAutoFit/>
+          </a:bodyPr>
+          <a:lstStyle/>
+          <a:p>
+            <a:pPr algn="ctr"/>
+            <a:r>
+              <a:rPr sz="1400" b="1" i="0">
+                <a:solidFill>
+                  <a:srgbClr val="005EB8"/>
+                </a:solidFill>
+                <a:latin typeface="Arial"/>
+              </a:rPr>
+              <a:t>→</a:t>
+            </a:r>
+          </a:p>
+        </p:txBody>
+      </p:sp>
+      <p:sp>
+        <p:nvSpPr>
+          <p:cNvPr id="41" name="TextBox 40"/>
+          <p:cNvSpPr txBox="1"/>
+          <p:nvPr/>
+        </p:nvSpPr>
+        <p:spPr>
+          <a:xfrm>
+            <a:off x="7933944" y="3026664"/>
+            <a:ext cx="256032" cy="274320"/>
+          </a:xfrm>
+          <a:prstGeom prst="rect">
+            <a:avLst/>
+          </a:prstGeom>
+          <a:noFill/>
+        </p:spPr>
+        <p:txBody>
+          <a:bodyPr wrap="square">
+            <a:spAutoFit/>
+          </a:bodyPr>
+          <a:lstStyle/>
+          <a:p>
+            <a:pPr algn="ctr"/>
+            <a:r>
+              <a:rPr sz="1400" b="1" i="0">
+                <a:solidFill>
+                  <a:srgbClr val="005EB8"/>
+                </a:solidFill>
+                <a:latin typeface="Arial"/>
+              </a:rPr>
+              <a:t>→</a:t>
+            </a:r>
+          </a:p>
+        </p:txBody>
+      </p:sp>
+      <p:sp>
+        <p:nvSpPr>
+          <p:cNvPr id="42" name="TextBox 41"/>
+          <p:cNvSpPr txBox="1"/>
+          <p:nvPr/>
+        </p:nvSpPr>
+        <p:spPr>
+          <a:xfrm>
+            <a:off x="9901428" y="3026664"/>
+            <a:ext cx="256032" cy="274320"/>
+          </a:xfrm>
+          <a:prstGeom prst="rect">
+            <a:avLst/>
+          </a:prstGeom>
+          <a:noFill/>
+        </p:spPr>
+        <p:txBody>
+          <a:bodyPr wrap="square">
+            <a:spAutoFit/>
+          </a:bodyPr>
+          <a:lstStyle/>
+          <a:p>
+            <a:pPr algn="ctr"/>
+            <a:r>
+              <a:rPr sz="1400" b="1" i="0">
+                <a:solidFill>
+                  <a:srgbClr val="005EB8"/>
+                </a:solidFill>
+                <a:latin typeface="Arial"/>
+              </a:rPr>
+              <a:t>→</a:t>
+            </a:r>
+          </a:p>
+        </p:txBody>
+      </p:sp>
       <p:sp>
         <p:nvSpPr>
           <p:cNvPr id="43" name="TextBox 42"/>
@@ -16050,146 +16050,146 @@
           </a:p>
         </p:txBody>
       </p:sp>
-      <p:cxnSp>
-        <p:nvCxnSpPr>
-          <p:cNvPr id="54" name="Connector 53"/>
-          <p:cNvCxnSpPr/>
-          <p:nvPr/>
-        </p:nvCxnSpPr>
-        <p:spPr>
-          <a:xfrm>
-            <a:off x="2443276" y="4306824"/>
-            <a:ext cx="219456" cy="0"/>
-          </a:xfrm>
-          <a:prstGeom prst="line">
-            <a:avLst/>
-          </a:prstGeom>
-          <a:ln w="19050">
-            <a:solidFill>
-              <a:srgbClr val="005EB8"/>
-            </a:solidFill>
-          </a:ln>
-        </p:spPr>
-        <p:style>
-          <a:lnRef idx="2">
-            <a:schemeClr val="accent1"/>
-          </a:lnRef>
-          <a:fillRef idx="0">
-            <a:schemeClr val="accent1"/>
-          </a:fillRef>
-          <a:effectRef idx="1">
-            <a:schemeClr val="accent1"/>
-          </a:effectRef>
-          <a:fontRef idx="minor">
-            <a:schemeClr val="tx1"/>
-          </a:fontRef>
-        </p:style>
-      </p:cxnSp>
-      <p:cxnSp>
-        <p:nvCxnSpPr>
-          <p:cNvPr id="55" name="Connector 54"/>
-          <p:cNvCxnSpPr/>
-          <p:nvPr/>
-        </p:nvCxnSpPr>
-        <p:spPr>
-          <a:xfrm>
-            <a:off x="4804257" y="4306824"/>
-            <a:ext cx="219456" cy="0"/>
-          </a:xfrm>
-          <a:prstGeom prst="line">
-            <a:avLst/>
-          </a:prstGeom>
-          <a:ln w="19050">
-            <a:solidFill>
-              <a:srgbClr val="005EB8"/>
-            </a:solidFill>
-          </a:ln>
-        </p:spPr>
-        <p:style>
-          <a:lnRef idx="2">
-            <a:schemeClr val="accent1"/>
-          </a:lnRef>
-          <a:fillRef idx="0">
-            <a:schemeClr val="accent1"/>
-          </a:fillRef>
-          <a:effectRef idx="1">
-            <a:schemeClr val="accent1"/>
-          </a:effectRef>
-          <a:fontRef idx="minor">
-            <a:schemeClr val="tx1"/>
-          </a:fontRef>
-        </p:style>
-      </p:cxnSp>
-      <p:cxnSp>
-        <p:nvCxnSpPr>
-          <p:cNvPr id="56" name="Connector 55"/>
-          <p:cNvCxnSpPr/>
-          <p:nvPr/>
-        </p:nvCxnSpPr>
-        <p:spPr>
-          <a:xfrm>
-            <a:off x="7165238" y="4306824"/>
-            <a:ext cx="219456" cy="0"/>
-          </a:xfrm>
-          <a:prstGeom prst="line">
-            <a:avLst/>
-          </a:prstGeom>
-          <a:ln w="19050">
-            <a:solidFill>
-              <a:srgbClr val="005EB8"/>
-            </a:solidFill>
-          </a:ln>
-        </p:spPr>
-        <p:style>
-          <a:lnRef idx="2">
-            <a:schemeClr val="accent1"/>
-          </a:lnRef>
-          <a:fillRef idx="0">
-            <a:schemeClr val="accent1"/>
-          </a:fillRef>
-          <a:effectRef idx="1">
-            <a:schemeClr val="accent1"/>
-          </a:effectRef>
-          <a:fontRef idx="minor">
-            <a:schemeClr val="tx1"/>
-          </a:fontRef>
-        </p:style>
-      </p:cxnSp>
-      <p:cxnSp>
-        <p:nvCxnSpPr>
-          <p:cNvPr id="57" name="Connector 56"/>
-          <p:cNvCxnSpPr/>
-          <p:nvPr/>
-        </p:nvCxnSpPr>
-        <p:spPr>
-          <a:xfrm>
-            <a:off x="9526219" y="4306824"/>
-            <a:ext cx="219456" cy="0"/>
-          </a:xfrm>
-          <a:prstGeom prst="line">
-            <a:avLst/>
-          </a:prstGeom>
-          <a:ln w="19050">
-            <a:solidFill>
-              <a:srgbClr val="005EB8"/>
-            </a:solidFill>
-          </a:ln>
-        </p:spPr>
-        <p:style>
-          <a:lnRef idx="2">
-            <a:schemeClr val="accent1"/>
-          </a:lnRef>
-          <a:fillRef idx="0">
-            <a:schemeClr val="accent1"/>
-          </a:fillRef>
-          <a:effectRef idx="1">
-            <a:schemeClr val="accent1"/>
-          </a:effectRef>
-          <a:fontRef idx="minor">
-            <a:schemeClr val="tx1"/>
-          </a:fontRef>
-        </p:style>
-      </p:cxnSp>
+      <p:sp>
+        <p:nvSpPr>
+          <p:cNvPr id="54" name="TextBox 53"/>
+          <p:cNvSpPr txBox="1"/>
+          <p:nvPr/>
+        </p:nvSpPr>
+        <p:spPr>
+          <a:xfrm>
+            <a:off x="2424988" y="4169663"/>
+            <a:ext cx="256032" cy="274320"/>
+          </a:xfrm>
+          <a:prstGeom prst="rect">
+            <a:avLst/>
+          </a:prstGeom>
+          <a:noFill/>
+        </p:spPr>
+        <p:txBody>
+          <a:bodyPr wrap="square">
+            <a:spAutoFit/>
+          </a:bodyPr>
+          <a:lstStyle/>
+          <a:p>
+            <a:pPr algn="ctr"/>
+            <a:r>
+              <a:rPr sz="1400" b="1" i="0">
+                <a:solidFill>
+                  <a:srgbClr val="005EB8"/>
+                </a:solidFill>
+                <a:latin typeface="Arial"/>
+              </a:rPr>
+              <a:t>→</a:t>
+            </a:r>
+          </a:p>
+        </p:txBody>
+      </p:sp>
+      <p:sp>
+        <p:nvSpPr>
+          <p:cNvPr id="55" name="TextBox 54"/>
+          <p:cNvSpPr txBox="1"/>
+          <p:nvPr/>
+        </p:nvSpPr>
+        <p:spPr>
+          <a:xfrm>
+            <a:off x="4785969" y="4169663"/>
+            <a:ext cx="256032" cy="274320"/>
+          </a:xfrm>
+          <a:prstGeom prst="rect">
+            <a:avLst/>
+          </a:prstGeom>
+          <a:noFill/>
+        </p:spPr>
+        <p:txBody>
+          <a:bodyPr wrap="square">
+            <a:spAutoFit/>
+          </a:bodyPr>
+          <a:lstStyle/>
+          <a:p>
+            <a:pPr algn="ctr"/>
+            <a:r>
+              <a:rPr sz="1400" b="1" i="0">
+                <a:solidFill>
+                  <a:srgbClr val="005EB8"/>
+                </a:solidFill>
+                <a:latin typeface="Arial"/>
+              </a:rPr>
+              <a:t>→</a:t>
+            </a:r>
+          </a:p>
+        </p:txBody>
+      </p:sp>
+      <p:sp>
+        <p:nvSpPr>
+          <p:cNvPr id="56" name="TextBox 55"/>
+          <p:cNvSpPr txBox="1"/>
+          <p:nvPr/>
+        </p:nvSpPr>
+        <p:spPr>
+          <a:xfrm>
+            <a:off x="7146950" y="4169663"/>
+            <a:ext cx="256032" cy="274320"/>
+          </a:xfrm>
+          <a:prstGeom prst="rect">
+            <a:avLst/>
+          </a:prstGeom>
+          <a:noFill/>
+        </p:spPr>
+        <p:txBody>
+          <a:bodyPr wrap="square">
+            <a:spAutoFit/>
+          </a:bodyPr>
+          <a:lstStyle/>
+          <a:p>
+            <a:pPr algn="ctr"/>
+            <a:r>
+              <a:rPr sz="1400" b="1" i="0">
+                <a:solidFill>
+                  <a:srgbClr val="005EB8"/>
+                </a:solidFill>
+                <a:latin typeface="Arial"/>
+              </a:rPr>
+              <a:t>→</a:t>
+            </a:r>
+          </a:p>
+        </p:txBody>
+      </p:sp>
+      <p:sp>
+        <p:nvSpPr>
+          <p:cNvPr id="57" name="TextBox 56"/>
+          <p:cNvSpPr txBox="1"/>
+          <p:nvPr/>
+        </p:nvSpPr>
+        <p:spPr>
+          <a:xfrm>
+            <a:off x="9507931" y="4169663"/>
+            <a:ext cx="256032" cy="274320"/>
+          </a:xfrm>
+          <a:prstGeom prst="rect">
+            <a:avLst/>
+          </a:prstGeom>
+          <a:noFill/>
+        </p:spPr>
+        <p:txBody>
+          <a:bodyPr wrap="square">
+            <a:spAutoFit/>
+          </a:bodyPr>
+          <a:lstStyle/>
+          <a:p>
+            <a:pPr algn="ctr"/>
+            <a:r>
+              <a:rPr sz="1400" b="1" i="0">
+                <a:solidFill>
+                  <a:srgbClr val="005EB8"/>
+                </a:solidFill>
+                <a:latin typeface="Arial"/>
+              </a:rPr>
+              <a:t>→</a:t>
+            </a:r>
+          </a:p>
+        </p:txBody>
+      </p:sp>
       <p:sp>
         <p:nvSpPr>
           <p:cNvPr id="58" name="Rectangle 57"/>
@@ -16773,41 +16773,41 @@
           </a:p>
         </p:txBody>
       </p:sp>
-      <p:cxnSp>
-        <p:nvCxnSpPr>
-          <p:cNvPr id="15" name="Connector 14"/>
-          <p:cNvCxnSpPr/>
-          <p:nvPr/>
-        </p:nvCxnSpPr>
-        <p:spPr>
-          <a:xfrm>
-            <a:off x="4133087" y="3657600"/>
-            <a:ext cx="320040" cy="0"/>
-          </a:xfrm>
-          <a:prstGeom prst="line">
-            <a:avLst/>
-          </a:prstGeom>
-          <a:ln w="25400">
-            <a:solidFill>
-              <a:srgbClr val="005EB8"/>
-            </a:solidFill>
-          </a:ln>
-        </p:spPr>
-        <p:style>
-          <a:lnRef idx="2">
-            <a:schemeClr val="accent1"/>
-          </a:lnRef>
-          <a:fillRef idx="0">
-            <a:schemeClr val="accent1"/>
-          </a:fillRef>
-          <a:effectRef idx="1">
-            <a:schemeClr val="accent1"/>
-          </a:effectRef>
-          <a:fontRef idx="minor">
-            <a:schemeClr val="tx1"/>
-          </a:fontRef>
-        </p:style>
-      </p:cxnSp>
+      <p:sp>
+        <p:nvSpPr>
+          <p:cNvPr id="15" name="TextBox 14"/>
+          <p:cNvSpPr txBox="1"/>
+          <p:nvPr/>
+        </p:nvSpPr>
+        <p:spPr>
+          <a:xfrm>
+            <a:off x="4133087" y="3429000"/>
+            <a:ext cx="320040" cy="274320"/>
+          </a:xfrm>
+          <a:prstGeom prst="rect">
+            <a:avLst/>
+          </a:prstGeom>
+          <a:noFill/>
+        </p:spPr>
+        <p:txBody>
+          <a:bodyPr wrap="square">
+            <a:spAutoFit/>
+          </a:bodyPr>
+          <a:lstStyle/>
+          <a:p>
+            <a:pPr algn="ctr"/>
+            <a:r>
+              <a:rPr sz="1800" b="1" i="0">
+                <a:solidFill>
+                  <a:srgbClr val="005EB8"/>
+                </a:solidFill>
+                <a:latin typeface="Arial"/>
+              </a:rPr>
+              <a:t>→</a:t>
+            </a:r>
+          </a:p>
+        </p:txBody>
+      </p:sp>
       <p:sp>
         <p:nvSpPr>
           <p:cNvPr id="16" name="Rectangle 15"/>
@@ -17096,41 +17096,41 @@
           </a:p>
         </p:txBody>
       </p:sp>
-      <p:cxnSp>
-        <p:nvCxnSpPr>
-          <p:cNvPr id="24" name="Connector 23"/>
-          <p:cNvCxnSpPr/>
-          <p:nvPr/>
-        </p:nvCxnSpPr>
-        <p:spPr>
-          <a:xfrm>
-            <a:off x="8266175" y="3657600"/>
-            <a:ext cx="320040" cy="0"/>
-          </a:xfrm>
-          <a:prstGeom prst="line">
-            <a:avLst/>
-          </a:prstGeom>
-          <a:ln w="25400">
-            <a:solidFill>
-              <a:srgbClr val="005EB8"/>
-            </a:solidFill>
-          </a:ln>
-        </p:spPr>
-        <p:style>
-          <a:lnRef idx="2">
-            <a:schemeClr val="accent1"/>
-          </a:lnRef>
-          <a:fillRef idx="0">
-            <a:schemeClr val="accent1"/>
-          </a:fillRef>
-          <a:effectRef idx="1">
-            <a:schemeClr val="accent1"/>
-          </a:effectRef>
-          <a:fontRef idx="minor">
-            <a:schemeClr val="tx1"/>
-          </a:fontRef>
-        </p:style>
-      </p:cxnSp>
+      <p:sp>
+        <p:nvSpPr>
+          <p:cNvPr id="24" name="TextBox 23"/>
+          <p:cNvSpPr txBox="1"/>
+          <p:nvPr/>
+        </p:nvSpPr>
+        <p:spPr>
+          <a:xfrm>
+            <a:off x="8266175" y="3429000"/>
+            <a:ext cx="320040" cy="274320"/>
+          </a:xfrm>
+          <a:prstGeom prst="rect">
+            <a:avLst/>
+          </a:prstGeom>
+          <a:noFill/>
+        </p:spPr>
+        <p:txBody>
+          <a:bodyPr wrap="square">
+            <a:spAutoFit/>
+          </a:bodyPr>
+          <a:lstStyle/>
+          <a:p>
+            <a:pPr algn="ctr"/>
+            <a:r>
+              <a:rPr sz="1800" b="1" i="0">
+                <a:solidFill>
+                  <a:srgbClr val="005EB8"/>
+                </a:solidFill>
+                <a:latin typeface="Arial"/>
+              </a:rPr>
+              <a:t>→</a:t>
+            </a:r>
+          </a:p>
+        </p:txBody>
+      </p:sp>
       <p:sp>
         <p:nvSpPr>
           <p:cNvPr id="25" name="Rectangle 24"/>
@@ -18002,41 +18002,41 @@
           </a:p>
         </p:txBody>
       </p:sp>
-      <p:cxnSp>
-        <p:nvCxnSpPr>
-          <p:cNvPr id="15" name="Connector 14"/>
-          <p:cNvCxnSpPr/>
-          <p:nvPr/>
-        </p:nvCxnSpPr>
-        <p:spPr>
-          <a:xfrm>
-            <a:off x="2578608" y="1463040"/>
-            <a:ext cx="274320" cy="0"/>
-          </a:xfrm>
-          <a:prstGeom prst="line">
-            <a:avLst/>
-          </a:prstGeom>
-          <a:ln w="19050">
-            <a:solidFill>
-              <a:srgbClr val="005EB8"/>
-            </a:solidFill>
-          </a:ln>
-        </p:spPr>
-        <p:style>
-          <a:lnRef idx="2">
-            <a:schemeClr val="accent1"/>
-          </a:lnRef>
-          <a:fillRef idx="0">
-            <a:schemeClr val="accent1"/>
-          </a:fillRef>
-          <a:effectRef idx="1">
-            <a:schemeClr val="accent1"/>
-          </a:effectRef>
-          <a:fontRef idx="minor">
-            <a:schemeClr val="tx1"/>
-          </a:fontRef>
-        </p:style>
-      </p:cxnSp>
+      <p:sp>
+        <p:nvSpPr>
+          <p:cNvPr id="15" name="TextBox 14"/>
+          <p:cNvSpPr txBox="1"/>
+          <p:nvPr/>
+        </p:nvSpPr>
+        <p:spPr>
+          <a:xfrm>
+            <a:off x="2578608" y="1325880"/>
+            <a:ext cx="274320" cy="274320"/>
+          </a:xfrm>
+          <a:prstGeom prst="rect">
+            <a:avLst/>
+          </a:prstGeom>
+          <a:noFill/>
+        </p:spPr>
+        <p:txBody>
+          <a:bodyPr wrap="square">
+            <a:spAutoFit/>
+          </a:bodyPr>
+          <a:lstStyle/>
+          <a:p>
+            <a:pPr algn="ctr"/>
+            <a:r>
+              <a:rPr sz="1400" b="1" i="0">
+                <a:solidFill>
+                  <a:srgbClr val="005EB8"/>
+                </a:solidFill>
+                <a:latin typeface="Arial"/>
+              </a:rPr>
+              <a:t>→</a:t>
+            </a:r>
+          </a:p>
+        </p:txBody>
+      </p:sp>
       <p:sp>
         <p:nvSpPr>
           <p:cNvPr id="16" name="Rectangle 15"/>
@@ -18255,41 +18255,41 @@
           </a:p>
         </p:txBody>
       </p:sp>
-      <p:cxnSp>
-        <p:nvCxnSpPr>
-          <p:cNvPr id="22" name="Connector 21"/>
-          <p:cNvCxnSpPr/>
-          <p:nvPr/>
-        </p:nvCxnSpPr>
-        <p:spPr>
-          <a:xfrm>
-            <a:off x="5111496" y="1463040"/>
-            <a:ext cx="274320" cy="0"/>
-          </a:xfrm>
-          <a:prstGeom prst="line">
-            <a:avLst/>
-          </a:prstGeom>
-          <a:ln w="19050">
-            <a:solidFill>
-              <a:srgbClr val="005EB8"/>
-            </a:solidFill>
-          </a:ln>
-        </p:spPr>
-        <p:style>
-          <a:lnRef idx="2">
-            <a:schemeClr val="accent1"/>
-          </a:lnRef>
-          <a:fillRef idx="0">
-            <a:schemeClr val="accent1"/>
-          </a:fillRef>
-          <a:effectRef idx="1">
-            <a:schemeClr val="accent1"/>
-          </a:effectRef>
-          <a:fontRef idx="minor">
-            <a:schemeClr val="tx1"/>
-          </a:fontRef>
-        </p:style>
-      </p:cxnSp>
+      <p:sp>
+        <p:nvSpPr>
+          <p:cNvPr id="22" name="TextBox 21"/>
+          <p:cNvSpPr txBox="1"/>
+          <p:nvPr/>
+        </p:nvSpPr>
+        <p:spPr>
+          <a:xfrm>
+            <a:off x="5111496" y="1325880"/>
+            <a:ext cx="274320" cy="274320"/>
+          </a:xfrm>
+          <a:prstGeom prst="rect">
+            <a:avLst/>
+          </a:prstGeom>
+          <a:noFill/>
+        </p:spPr>
+        <p:txBody>
+          <a:bodyPr wrap="square">
+            <a:spAutoFit/>
+          </a:bodyPr>
+          <a:lstStyle/>
+          <a:p>
+            <a:pPr algn="ctr"/>
+            <a:r>
+              <a:rPr sz="1400" b="1" i="0">
+                <a:solidFill>
+                  <a:srgbClr val="005EB8"/>
+                </a:solidFill>
+                <a:latin typeface="Arial"/>
+              </a:rPr>
+              <a:t>→</a:t>
+            </a:r>
+          </a:p>
+        </p:txBody>
+      </p:sp>
       <p:sp>
         <p:nvSpPr>
           <p:cNvPr id="23" name="Rectangle 22"/>
@@ -18508,41 +18508,41 @@
           </a:p>
         </p:txBody>
       </p:sp>
-      <p:cxnSp>
-        <p:nvCxnSpPr>
-          <p:cNvPr id="29" name="Connector 28"/>
-          <p:cNvCxnSpPr/>
-          <p:nvPr/>
-        </p:nvCxnSpPr>
-        <p:spPr>
-          <a:xfrm>
-            <a:off x="7644384" y="1463040"/>
-            <a:ext cx="274320" cy="0"/>
-          </a:xfrm>
-          <a:prstGeom prst="line">
-            <a:avLst/>
-          </a:prstGeom>
-          <a:ln w="19050">
-            <a:solidFill>
-              <a:srgbClr val="005EB8"/>
-            </a:solidFill>
-          </a:ln>
-        </p:spPr>
-        <p:style>
-          <a:lnRef idx="2">
-            <a:schemeClr val="accent1"/>
-          </a:lnRef>
-          <a:fillRef idx="0">
-            <a:schemeClr val="accent1"/>
-          </a:fillRef>
-          <a:effectRef idx="1">
-            <a:schemeClr val="accent1"/>
-          </a:effectRef>
-          <a:fontRef idx="minor">
-            <a:schemeClr val="tx1"/>
-          </a:fontRef>
-        </p:style>
-      </p:cxnSp>
+      <p:sp>
+        <p:nvSpPr>
+          <p:cNvPr id="29" name="TextBox 28"/>
+          <p:cNvSpPr txBox="1"/>
+          <p:nvPr/>
+        </p:nvSpPr>
+        <p:spPr>
+          <a:xfrm>
+            <a:off x="7644384" y="1325880"/>
+            <a:ext cx="274320" cy="274320"/>
+          </a:xfrm>
+          <a:prstGeom prst="rect">
+            <a:avLst/>
+          </a:prstGeom>
+          <a:noFill/>
+        </p:spPr>
+        <p:txBody>
+          <a:bodyPr wrap="square">
+            <a:spAutoFit/>
+          </a:bodyPr>
+          <a:lstStyle/>
+          <a:p>
+            <a:pPr algn="ctr"/>
+            <a:r>
+              <a:rPr sz="1400" b="1" i="0">
+                <a:solidFill>
+                  <a:srgbClr val="005EB8"/>
+                </a:solidFill>
+                <a:latin typeface="Arial"/>
+              </a:rPr>
+              <a:t>→</a:t>
+            </a:r>
+          </a:p>
+        </p:txBody>
+      </p:sp>
       <p:sp>
         <p:nvSpPr>
           <p:cNvPr id="30" name="Rectangle 29"/>
@@ -18761,41 +18761,41 @@
           </a:p>
         </p:txBody>
       </p:sp>
-      <p:cxnSp>
-        <p:nvCxnSpPr>
-          <p:cNvPr id="36" name="Connector 35"/>
-          <p:cNvCxnSpPr/>
-          <p:nvPr/>
-        </p:nvCxnSpPr>
-        <p:spPr>
-          <a:xfrm>
-            <a:off x="10177272" y="1463040"/>
-            <a:ext cx="274320" cy="0"/>
-          </a:xfrm>
-          <a:prstGeom prst="line">
-            <a:avLst/>
-          </a:prstGeom>
-          <a:ln w="19050">
-            <a:solidFill>
-              <a:srgbClr val="005EB8"/>
-            </a:solidFill>
-          </a:ln>
-        </p:spPr>
-        <p:style>
-          <a:lnRef idx="2">
-            <a:schemeClr val="accent1"/>
-          </a:lnRef>
-          <a:fillRef idx="0">
-            <a:schemeClr val="accent1"/>
-          </a:fillRef>
-          <a:effectRef idx="1">
-            <a:schemeClr val="accent1"/>
-          </a:effectRef>
-          <a:fontRef idx="minor">
-            <a:schemeClr val="tx1"/>
-          </a:fontRef>
-        </p:style>
-      </p:cxnSp>
+      <p:sp>
+        <p:nvSpPr>
+          <p:cNvPr id="36" name="TextBox 35"/>
+          <p:cNvSpPr txBox="1"/>
+          <p:nvPr/>
+        </p:nvSpPr>
+        <p:spPr>
+          <a:xfrm>
+            <a:off x="10177272" y="1325880"/>
+            <a:ext cx="274320" cy="274320"/>
+          </a:xfrm>
+          <a:prstGeom prst="rect">
+            <a:avLst/>
+          </a:prstGeom>
+          <a:noFill/>
+        </p:spPr>
+        <p:txBody>
+          <a:bodyPr wrap="square">
+            <a:spAutoFit/>
+          </a:bodyPr>
+          <a:lstStyle/>
+          <a:p>
+            <a:pPr algn="ctr"/>
+            <a:r>
+              <a:rPr sz="1400" b="1" i="0">
+                <a:solidFill>
+                  <a:srgbClr val="005EB8"/>
+                </a:solidFill>
+                <a:latin typeface="Arial"/>
+              </a:rPr>
+              <a:t>→</a:t>
+            </a:r>
+          </a:p>
+        </p:txBody>
+      </p:sp>
       <p:sp>
         <p:nvSpPr>
           <p:cNvPr id="37" name="Rectangle 36"/>
@@ -19720,41 +19720,41 @@
           </a:p>
         </p:txBody>
       </p:sp>
-      <p:cxnSp>
-        <p:nvCxnSpPr>
-          <p:cNvPr id="13" name="Connector 12"/>
-          <p:cNvCxnSpPr/>
-          <p:nvPr/>
-        </p:nvCxnSpPr>
-        <p:spPr>
-          <a:xfrm>
-            <a:off x="2578608" y="1463040"/>
-            <a:ext cx="274320" cy="0"/>
-          </a:xfrm>
-          <a:prstGeom prst="line">
-            <a:avLst/>
-          </a:prstGeom>
-          <a:ln w="19050">
-            <a:solidFill>
-              <a:srgbClr val="005EB8"/>
-            </a:solidFill>
-          </a:ln>
-        </p:spPr>
-        <p:style>
-          <a:lnRef idx="2">
-            <a:schemeClr val="accent1"/>
-          </a:lnRef>
-          <a:fillRef idx="0">
-            <a:schemeClr val="accent1"/>
-          </a:fillRef>
-          <a:effectRef idx="1">
-            <a:schemeClr val="accent1"/>
-          </a:effectRef>
-          <a:fontRef idx="minor">
-            <a:schemeClr val="tx1"/>
-          </a:fontRef>
-        </p:style>
-      </p:cxnSp>
+      <p:sp>
+        <p:nvSpPr>
+          <p:cNvPr id="13" name="TextBox 12"/>
+          <p:cNvSpPr txBox="1"/>
+          <p:nvPr/>
+        </p:nvSpPr>
+        <p:spPr>
+          <a:xfrm>
+            <a:off x="2578608" y="1325880"/>
+            <a:ext cx="274320" cy="274320"/>
+          </a:xfrm>
+          <a:prstGeom prst="rect">
+            <a:avLst/>
+          </a:prstGeom>
+          <a:noFill/>
+        </p:spPr>
+        <p:txBody>
+          <a:bodyPr wrap="square">
+            <a:spAutoFit/>
+          </a:bodyPr>
+          <a:lstStyle/>
+          <a:p>
+            <a:pPr algn="ctr"/>
+            <a:r>
+              <a:rPr sz="1400" b="1" i="0">
+                <a:solidFill>
+                  <a:srgbClr val="005EB8"/>
+                </a:solidFill>
+                <a:latin typeface="Arial"/>
+              </a:rPr>
+              <a:t>→</a:t>
+            </a:r>
+          </a:p>
+        </p:txBody>
+      </p:sp>
       <p:sp>
         <p:nvSpPr>
           <p:cNvPr id="14" name="Rectangle 13"/>
@@ -19973,41 +19973,41 @@
           </a:p>
         </p:txBody>
       </p:sp>
-      <p:cxnSp>
-        <p:nvCxnSpPr>
-          <p:cNvPr id="20" name="Connector 19"/>
-          <p:cNvCxnSpPr/>
-          <p:nvPr/>
-        </p:nvCxnSpPr>
-        <p:spPr>
-          <a:xfrm>
-            <a:off x="5111496" y="1463040"/>
-            <a:ext cx="274320" cy="0"/>
-          </a:xfrm>
-          <a:prstGeom prst="line">
-            <a:avLst/>
-          </a:prstGeom>
-          <a:ln w="19050">
-            <a:solidFill>
-              <a:srgbClr val="005EB8"/>
-            </a:solidFill>
-          </a:ln>
-        </p:spPr>
-        <p:style>
-          <a:lnRef idx="2">
-            <a:schemeClr val="accent1"/>
-          </a:lnRef>
-          <a:fillRef idx="0">
-            <a:schemeClr val="accent1"/>
-          </a:fillRef>
-          <a:effectRef idx="1">
-            <a:schemeClr val="accent1"/>
-          </a:effectRef>
-          <a:fontRef idx="minor">
-            <a:schemeClr val="tx1"/>
-          </a:fontRef>
-        </p:style>
-      </p:cxnSp>
+      <p:sp>
+        <p:nvSpPr>
+          <p:cNvPr id="20" name="TextBox 19"/>
+          <p:cNvSpPr txBox="1"/>
+          <p:nvPr/>
+        </p:nvSpPr>
+        <p:spPr>
+          <a:xfrm>
+            <a:off x="5111496" y="1325880"/>
+            <a:ext cx="274320" cy="274320"/>
+          </a:xfrm>
+          <a:prstGeom prst="rect">
+            <a:avLst/>
+          </a:prstGeom>
+          <a:noFill/>
+        </p:spPr>
+        <p:txBody>
+          <a:bodyPr wrap="square">
+            <a:spAutoFit/>
+          </a:bodyPr>
+          <a:lstStyle/>
+          <a:p>
+            <a:pPr algn="ctr"/>
+            <a:r>
+              <a:rPr sz="1400" b="1" i="0">
+                <a:solidFill>
+                  <a:srgbClr val="005EB8"/>
+                </a:solidFill>
+                <a:latin typeface="Arial"/>
+              </a:rPr>
+              <a:t>→</a:t>
+            </a:r>
+          </a:p>
+        </p:txBody>
+      </p:sp>
       <p:sp>
         <p:nvSpPr>
           <p:cNvPr id="21" name="Rectangle 20"/>
@@ -20226,41 +20226,41 @@
           </a:p>
         </p:txBody>
       </p:sp>
-      <p:cxnSp>
-        <p:nvCxnSpPr>
-          <p:cNvPr id="27" name="Connector 26"/>
-          <p:cNvCxnSpPr/>
-          <p:nvPr/>
-        </p:nvCxnSpPr>
-        <p:spPr>
-          <a:xfrm>
-            <a:off x="7644384" y="1463040"/>
-            <a:ext cx="274320" cy="0"/>
-          </a:xfrm>
-          <a:prstGeom prst="line">
-            <a:avLst/>
-          </a:prstGeom>
-          <a:ln w="19050">
-            <a:solidFill>
-              <a:srgbClr val="005EB8"/>
-            </a:solidFill>
-          </a:ln>
-        </p:spPr>
-        <p:style>
-          <a:lnRef idx="2">
-            <a:schemeClr val="accent1"/>
-          </a:lnRef>
-          <a:fillRef idx="0">
-            <a:schemeClr val="accent1"/>
-          </a:fillRef>
-          <a:effectRef idx="1">
-            <a:schemeClr val="accent1"/>
-          </a:effectRef>
-          <a:fontRef idx="minor">
-            <a:schemeClr val="tx1"/>
-          </a:fontRef>
-        </p:style>
-      </p:cxnSp>
+      <p:sp>
+        <p:nvSpPr>
+          <p:cNvPr id="27" name="TextBox 26"/>
+          <p:cNvSpPr txBox="1"/>
+          <p:nvPr/>
+        </p:nvSpPr>
+        <p:spPr>
+          <a:xfrm>
+            <a:off x="7644384" y="1325880"/>
+            <a:ext cx="274320" cy="274320"/>
+          </a:xfrm>
+          <a:prstGeom prst="rect">
+            <a:avLst/>
+          </a:prstGeom>
+          <a:noFill/>
+        </p:spPr>
+        <p:txBody>
+          <a:bodyPr wrap="square">
+            <a:spAutoFit/>
+          </a:bodyPr>
+          <a:lstStyle/>
+          <a:p>
+            <a:pPr algn="ctr"/>
+            <a:r>
+              <a:rPr sz="1400" b="1" i="0">
+                <a:solidFill>
+                  <a:srgbClr val="005EB8"/>
+                </a:solidFill>
+                <a:latin typeface="Arial"/>
+              </a:rPr>
+              <a:t>→</a:t>
+            </a:r>
+          </a:p>
+        </p:txBody>
+      </p:sp>
       <p:sp>
         <p:nvSpPr>
           <p:cNvPr id="28" name="Rectangle 27"/>
@@ -20479,41 +20479,41 @@
           </a:p>
         </p:txBody>
       </p:sp>
-      <p:cxnSp>
-        <p:nvCxnSpPr>
-          <p:cNvPr id="34" name="Connector 33"/>
-          <p:cNvCxnSpPr/>
-          <p:nvPr/>
-        </p:nvCxnSpPr>
-        <p:spPr>
-          <a:xfrm>
-            <a:off x="10177272" y="1463040"/>
-            <a:ext cx="274320" cy="0"/>
-          </a:xfrm>
-          <a:prstGeom prst="line">
-            <a:avLst/>
-          </a:prstGeom>
-          <a:ln w="19050">
-            <a:solidFill>
-              <a:srgbClr val="005EB8"/>
-            </a:solidFill>
-          </a:ln>
-        </p:spPr>
-        <p:style>
-          <a:lnRef idx="2">
-            <a:schemeClr val="accent1"/>
-          </a:lnRef>
-          <a:fillRef idx="0">
-            <a:schemeClr val="accent1"/>
-          </a:fillRef>
-          <a:effectRef idx="1">
-            <a:schemeClr val="accent1"/>
-          </a:effectRef>
-          <a:fontRef idx="minor">
-            <a:schemeClr val="tx1"/>
-          </a:fontRef>
-        </p:style>
-      </p:cxnSp>
+      <p:sp>
+        <p:nvSpPr>
+          <p:cNvPr id="34" name="TextBox 33"/>
+          <p:cNvSpPr txBox="1"/>
+          <p:nvPr/>
+        </p:nvSpPr>
+        <p:spPr>
+          <a:xfrm>
+            <a:off x="10177272" y="1325880"/>
+            <a:ext cx="274320" cy="274320"/>
+          </a:xfrm>
+          <a:prstGeom prst="rect">
+            <a:avLst/>
+          </a:prstGeom>
+          <a:noFill/>
+        </p:spPr>
+        <p:txBody>
+          <a:bodyPr wrap="square">
+            <a:spAutoFit/>
+          </a:bodyPr>
+          <a:lstStyle/>
+          <a:p>
+            <a:pPr algn="ctr"/>
+            <a:r>
+              <a:rPr sz="1400" b="1" i="0">
+                <a:solidFill>
+                  <a:srgbClr val="005EB8"/>
+                </a:solidFill>
+                <a:latin typeface="Arial"/>
+              </a:rPr>
+              <a:t>→</a:t>
+            </a:r>
+          </a:p>
+        </p:txBody>
+      </p:sp>
       <p:sp>
         <p:nvSpPr>
           <p:cNvPr id="35" name="Rectangle 34"/>

</xml_diff>